<commit_message>
fix: sanitize publication text and metadata with verified original archives
</commit_message>
<xml_diff>
--- a/dokumente/wirkungsoekonomie-akademie-master-template.pptx
+++ b/dokumente/wirkungsoekonomie-akademie-master-template.pptx
@@ -265,9 +265,9 @@
 </file>
 
 <file path=ppt/notesMasters/theme/theme2.xml><?xml version="1.0" encoding="utf-8"?>
-<a:theme xmlns:a="http://schemas.openxmlformats.org/drawingml/2006/main" name="ChatGPT">
+<a:theme xmlns:a="http://schemas.openxmlformats.org/drawingml/2006/main" name="Wirkungsoekonomie">
   <a:themeElements>
-    <a:clrScheme name="ChatGPT">
+    <a:clrScheme name="Wirkungsoekonomie">
       <a:dk1>
         <a:srgbClr val="000000"/>
       </a:dk1>
@@ -317,7 +317,7 @@
         <a:cs typeface="Calibri"/>
       </a:minorFont>
     </a:fontScheme>
-    <a:fmtScheme name="ChatGPT">
+    <a:fmtScheme name="Wirkungsoekonomie">
       <a:fillStyleLst>
         <a:solidFill>
           <a:schemeClr val="phClr"/>
@@ -17968,9 +17968,9 @@
 </file>
 
 <file path=ppt/theme/theme1.xml><?xml version="1.0" encoding="utf-8"?>
-<a:theme xmlns:a="http://schemas.openxmlformats.org/drawingml/2006/main" name="ChatGPT">
+<a:theme xmlns:a="http://schemas.openxmlformats.org/drawingml/2006/main" name="Wirkungsoekonomie">
   <a:themeElements>
-    <a:clrScheme name="ChatGPT">
+    <a:clrScheme name="Wirkungsoekonomie">
       <a:dk1>
         <a:srgbClr val="000000"/>
       </a:dk1>
@@ -18020,7 +18020,7 @@
         <a:cs typeface="Calibri"/>
       </a:minorFont>
     </a:fontScheme>
-    <a:fmtScheme name="ChatGPT">
+    <a:fmtScheme name="Wirkungsoekonomie">
       <a:fillStyleLst>
         <a:solidFill>
           <a:schemeClr val="phClr"/>

</xml_diff>

<commit_message>
chore: Oracle Wirkungsticker wake-up 2026-09-06T14:50:09Z
</commit_message>
<xml_diff>
--- a/dokumente/wirkungsoekonomie-akademie-master-template.pptx
+++ b/dokumente/wirkungsoekonomie-akademie-master-template.pptx
@@ -265,9 +265,9 @@
 </file>
 
 <file path=ppt/notesMasters/theme/theme2.xml><?xml version="1.0" encoding="utf-8"?>
-<a:theme xmlns:a="http://schemas.openxmlformats.org/drawingml/2006/main" name="ChatGPT">
+<a:theme xmlns:a="http://schemas.openxmlformats.org/drawingml/2006/main" name="Wirkungsoekonomie">
   <a:themeElements>
-    <a:clrScheme name="ChatGPT">
+    <a:clrScheme name="Wirkungsoekonomie">
       <a:dk1>
         <a:srgbClr val="000000"/>
       </a:dk1>
@@ -317,7 +317,7 @@
         <a:cs typeface="Calibri"/>
       </a:minorFont>
     </a:fontScheme>
-    <a:fmtScheme name="ChatGPT">
+    <a:fmtScheme name="Wirkungsoekonomie">
       <a:fillStyleLst>
         <a:solidFill>
           <a:schemeClr val="phClr"/>
@@ -17968,9 +17968,9 @@
 </file>
 
 <file path=ppt/theme/theme1.xml><?xml version="1.0" encoding="utf-8"?>
-<a:theme xmlns:a="http://schemas.openxmlformats.org/drawingml/2006/main" name="ChatGPT">
+<a:theme xmlns:a="http://schemas.openxmlformats.org/drawingml/2006/main" name="Wirkungsoekonomie">
   <a:themeElements>
-    <a:clrScheme name="ChatGPT">
+    <a:clrScheme name="Wirkungsoekonomie">
       <a:dk1>
         <a:srgbClr val="000000"/>
       </a:dk1>
@@ -18020,7 +18020,7 @@
         <a:cs typeface="Calibri"/>
       </a:minorFont>
     </a:fontScheme>
-    <a:fmtScheme name="ChatGPT">
+    <a:fmtScheme name="Wirkungsoekonomie">
       <a:fillStyleLst>
         <a:solidFill>
           <a:schemeClr val="phClr"/>

</xml_diff>

<commit_message>
chore: Oracle Wirkungsticker wake-up 2026-09-06T18:05:27Z
</commit_message>
<xml_diff>
--- a/dokumente/wirkungsoekonomie-akademie-master-template.pptx
+++ b/dokumente/wirkungsoekonomie-akademie-master-template.pptx
@@ -265,9 +265,9 @@
 </file>
 
 <file path=ppt/notesMasters/theme/theme2.xml><?xml version="1.0" encoding="utf-8"?>
-<a:theme xmlns:a="http://schemas.openxmlformats.org/drawingml/2006/main" name="ChatGPT">
+<a:theme xmlns:a="http://schemas.openxmlformats.org/drawingml/2006/main" name="Wirkungsoekonomie">
   <a:themeElements>
-    <a:clrScheme name="ChatGPT">
+    <a:clrScheme name="Wirkungsoekonomie">
       <a:dk1>
         <a:srgbClr val="000000"/>
       </a:dk1>
@@ -317,7 +317,7 @@
         <a:cs typeface="Calibri"/>
       </a:minorFont>
     </a:fontScheme>
-    <a:fmtScheme name="ChatGPT">
+    <a:fmtScheme name="Wirkungsoekonomie">
       <a:fillStyleLst>
         <a:solidFill>
           <a:schemeClr val="phClr"/>
@@ -17968,9 +17968,9 @@
 </file>
 
 <file path=ppt/theme/theme1.xml><?xml version="1.0" encoding="utf-8"?>
-<a:theme xmlns:a="http://schemas.openxmlformats.org/drawingml/2006/main" name="ChatGPT">
+<a:theme xmlns:a="http://schemas.openxmlformats.org/drawingml/2006/main" name="Wirkungsoekonomie">
   <a:themeElements>
-    <a:clrScheme name="ChatGPT">
+    <a:clrScheme name="Wirkungsoekonomie">
       <a:dk1>
         <a:srgbClr val="000000"/>
       </a:dk1>
@@ -18020,7 +18020,7 @@
         <a:cs typeface="Calibri"/>
       </a:minorFont>
     </a:fontScheme>
-    <a:fmtScheme name="ChatGPT">
+    <a:fmtScheme name="Wirkungsoekonomie">
       <a:fillStyleLst>
         <a:solidFill>
           <a:schemeClr val="phClr"/>

</xml_diff>